<commit_message>
Align target decks with print index
</commit_message>
<xml_diff>
--- a/STARLAB_Slide_Decks_All/17_Oral_Presentation_Skills_for_Research.pptx
+++ b/STARLAB_Slide_Decks_All/17_Oral_Presentation_Skills_for_Research.pptx
@@ -2,38 +2,38 @@
 <file path=ppt/presentation.xml><?xml version="1.0" encoding="utf-8"?>
 <p:presentation xmlns:p="http://schemas.openxmlformats.org/presentationml/2006/main" embedTrueTypeFonts="1" saveSubsetFonts="0">
   <p:sldMasterIdLst>
-    <p:sldMasterId xmlns:r="http://schemas.openxmlformats.org/officeDocument/2006/relationships" id="2147483648" r:id="R5464915e28264aa1"/>
+    <p:sldMasterId xmlns:r="http://schemas.openxmlformats.org/officeDocument/2006/relationships" id="2147483648" r:id="R945a855af0164ef9"/>
   </p:sldMasterIdLst>
   <p:notesMasterIdLst>
-    <p:notesMasterId xmlns:r="http://schemas.openxmlformats.org/officeDocument/2006/relationships" r:id="R1b2b8f0713de40b0"/>
+    <p:notesMasterId xmlns:r="http://schemas.openxmlformats.org/officeDocument/2006/relationships" r:id="R0b6042d49d7547cc"/>
   </p:notesMasterIdLst>
   <p:sldIdLst>
-    <p:sldId xmlns:r="http://schemas.openxmlformats.org/officeDocument/2006/relationships" id="256" r:id="Rd2ae22b248d84729"/>
-    <p:sldId xmlns:r="http://schemas.openxmlformats.org/officeDocument/2006/relationships" id="257" r:id="Rf639bd9d9ce249b9"/>
-    <p:sldId xmlns:r="http://schemas.openxmlformats.org/officeDocument/2006/relationships" id="258" r:id="Rd95f636c98004c99"/>
-    <p:sldId xmlns:r="http://schemas.openxmlformats.org/officeDocument/2006/relationships" id="259" r:id="R58318f8b6873413f"/>
-    <p:sldId xmlns:r="http://schemas.openxmlformats.org/officeDocument/2006/relationships" id="260" r:id="Rf9a8004bb32c4086"/>
-    <p:sldId xmlns:r="http://schemas.openxmlformats.org/officeDocument/2006/relationships" id="261" r:id="R5d6784842d364fb6"/>
-    <p:sldId xmlns:r="http://schemas.openxmlformats.org/officeDocument/2006/relationships" id="262" r:id="R1078db1e47f04425"/>
-    <p:sldId xmlns:r="http://schemas.openxmlformats.org/officeDocument/2006/relationships" id="263" r:id="R54cb70e4ac2843d2"/>
-    <p:sldId xmlns:r="http://schemas.openxmlformats.org/officeDocument/2006/relationships" id="264" r:id="Re9de652a37604432"/>
-    <p:sldId xmlns:r="http://schemas.openxmlformats.org/officeDocument/2006/relationships" id="265" r:id="Rc9ce11df569a4165"/>
-    <p:sldId xmlns:r="http://schemas.openxmlformats.org/officeDocument/2006/relationships" id="266" r:id="R71178aa2bf454b14"/>
-    <p:sldId xmlns:r="http://schemas.openxmlformats.org/officeDocument/2006/relationships" id="267" r:id="R1505cfc5f58d4ed0"/>
-    <p:sldId xmlns:r="http://schemas.openxmlformats.org/officeDocument/2006/relationships" id="268" r:id="Rae1da28e8d3c4aff"/>
-    <p:sldId xmlns:r="http://schemas.openxmlformats.org/officeDocument/2006/relationships" id="269" r:id="R785e8e15fe714e81"/>
-    <p:sldId xmlns:r="http://schemas.openxmlformats.org/officeDocument/2006/relationships" id="270" r:id="R327efa09780c46b8"/>
-    <p:sldId xmlns:r="http://schemas.openxmlformats.org/officeDocument/2006/relationships" id="271" r:id="R43dd19d251524cea"/>
-    <p:sldId xmlns:r="http://schemas.openxmlformats.org/officeDocument/2006/relationships" id="272" r:id="Red4209b6c30f4dd5"/>
-    <p:sldId xmlns:r="http://schemas.openxmlformats.org/officeDocument/2006/relationships" id="273" r:id="Rceb484dbaac14004"/>
+    <p:sldId xmlns:r="http://schemas.openxmlformats.org/officeDocument/2006/relationships" id="256" r:id="R3730e15c46b54ebd"/>
+    <p:sldId xmlns:r="http://schemas.openxmlformats.org/officeDocument/2006/relationships" id="257" r:id="Rd2fd000998ae4926"/>
+    <p:sldId xmlns:r="http://schemas.openxmlformats.org/officeDocument/2006/relationships" id="258" r:id="Rda7043123c714b43"/>
+    <p:sldId xmlns:r="http://schemas.openxmlformats.org/officeDocument/2006/relationships" id="259" r:id="R4ea63cc0c44b44df"/>
+    <p:sldId xmlns:r="http://schemas.openxmlformats.org/officeDocument/2006/relationships" id="260" r:id="R84bffb6d39f6441f"/>
+    <p:sldId xmlns:r="http://schemas.openxmlformats.org/officeDocument/2006/relationships" id="261" r:id="R1b7ca2342e8c4cdd"/>
+    <p:sldId xmlns:r="http://schemas.openxmlformats.org/officeDocument/2006/relationships" id="262" r:id="Recb18dacdf294cdc"/>
+    <p:sldId xmlns:r="http://schemas.openxmlformats.org/officeDocument/2006/relationships" id="263" r:id="R283cdefa3f8b4fff"/>
+    <p:sldId xmlns:r="http://schemas.openxmlformats.org/officeDocument/2006/relationships" id="264" r:id="Rf24078616ed34fae"/>
+    <p:sldId xmlns:r="http://schemas.openxmlformats.org/officeDocument/2006/relationships" id="265" r:id="Raed96b2932d24c9f"/>
+    <p:sldId xmlns:r="http://schemas.openxmlformats.org/officeDocument/2006/relationships" id="266" r:id="R0093ce3ae5fc49e5"/>
+    <p:sldId xmlns:r="http://schemas.openxmlformats.org/officeDocument/2006/relationships" id="267" r:id="R443049c1571f401c"/>
+    <p:sldId xmlns:r="http://schemas.openxmlformats.org/officeDocument/2006/relationships" id="268" r:id="R445d8c106c314728"/>
+    <p:sldId xmlns:r="http://schemas.openxmlformats.org/officeDocument/2006/relationships" id="269" r:id="Ra7b1cfa203b5401f"/>
+    <p:sldId xmlns:r="http://schemas.openxmlformats.org/officeDocument/2006/relationships" id="270" r:id="R304ba13e14a64174"/>
+    <p:sldId xmlns:r="http://schemas.openxmlformats.org/officeDocument/2006/relationships" id="271" r:id="Rdf002cba29e142f1"/>
+    <p:sldId xmlns:r="http://schemas.openxmlformats.org/officeDocument/2006/relationships" id="272" r:id="R3d45b7e9d0c14f1d"/>
+    <p:sldId xmlns:r="http://schemas.openxmlformats.org/officeDocument/2006/relationships" id="273" r:id="Rff4aca07dac34cc4"/>
   </p:sldIdLst>
   <p:sldSz cx="12192000" cy="6858000"/>
   <p:notesSz cx="6858000" cy="9144000"/>
   <p:embeddedFontLst>
     <p:embeddedFont>
       <p:font typeface="Play"/>
-      <p:regular xmlns:r="http://schemas.openxmlformats.org/officeDocument/2006/relationships" r:id="R0b0c79c9c8d84c96"/>
-      <p:bold xmlns:r="http://schemas.openxmlformats.org/officeDocument/2006/relationships" r:id="Rf42b35074b8a49cd"/>
+      <p:regular xmlns:r="http://schemas.openxmlformats.org/officeDocument/2006/relationships" r:id="R7a6e534c5a914f4d"/>
+      <p:bold xmlns:r="http://schemas.openxmlformats.org/officeDocument/2006/relationships" r:id="Rcfa74da544c24431"/>
     </p:embeddedFont>
   </p:embeddedFontLst>
   <p:defaultTextStyle>
@@ -831,6 +831,48 @@
               <a:buNone/>
             </a:pPr>
             <a:r>
+              <a:t>OPTIONAL / TEACHER SCORING REFERENCE</a:t>
+            </a:r>
+          </a:p>
+          <a:p xmlns:a="http://schemas.openxmlformats.org/drawingml/2006/main">
+            <a:pPr marL="0" indent="0" algn="l">
+              <a:spcBef>
+                <a:spcPts val="0"/>
+              </a:spcBef>
+              <a:spcAft>
+                <a:spcPts val="0"/>
+              </a:spcAft>
+              <a:buNone/>
+            </a:pPr>
+            <a:r>
+              <a:t>- Unit 6 Appendix L: Oral Presentation Rubric (final summative rubric; may be used to guide practice feedback)</a:t>
+            </a:r>
+          </a:p>
+          <a:p xmlns:a="http://schemas.openxmlformats.org/drawingml/2006/main">
+            <a:pPr marL="0" indent="0" algn="l">
+              <a:spcBef>
+                <a:spcPts val="0"/>
+              </a:spcBef>
+              <a:spcAft>
+                <a:spcPts val="0"/>
+              </a:spcAft>
+              <a:buNone/>
+            </a:pPr>
+            <a:r>
+              <a:t/>
+            </a:r>
+          </a:p>
+          <a:p xmlns:a="http://schemas.openxmlformats.org/drawingml/2006/main">
+            <a:pPr marL="0" indent="0" algn="l">
+              <a:spcBef>
+                <a:spcPts val="0"/>
+              </a:spcBef>
+              <a:spcAft>
+                <a:spcPts val="0"/>
+              </a:spcAft>
+              <a:buNone/>
+            </a:pPr>
+            <a:r>
               <a:t>RESOURCE ALIGNMENT</a:t>
             </a:r>
           </a:p>
@@ -2479,7 +2521,7 @@
   </p:cSld>
   <p:clrMap bg1="lt1" tx1="dk1" bg2="dk2" tx2="lt2" accent1="accent1" accent2="accent2" accent3="accent3" accent4="accent4" accent5="accent5" accent6="accent6" hlink="hlink" folHlink="folHlink"/>
   <p:sldLayoutIdLst>
-    <p:sldLayoutId xmlns:r="http://schemas.openxmlformats.org/officeDocument/2006/relationships" id="2147483649" r:id="R8f4d38f2e3bf4e5a"/>
+    <p:sldLayoutId xmlns:r="http://schemas.openxmlformats.org/officeDocument/2006/relationships" id="2147483649" r:id="Rc6c6eee8d1534892"/>
   </p:sldLayoutIdLst>
   <p:hf sldNum="0" hdr="0" ftr="0" dt="0"/>
   <p:txStyles>
@@ -3602,7 +3644,7 @@
           <p:nvPr/>
         </p:nvPicPr>
         <p:blipFill rotWithShape="1">
-          <a:blip xmlns:r="http://schemas.openxmlformats.org/officeDocument/2006/relationships" xmlns:a="http://schemas.openxmlformats.org/drawingml/2006/main" r:embed="R48c0961a15c3496b">
+          <a:blip xmlns:r="http://schemas.openxmlformats.org/officeDocument/2006/relationships" xmlns:a="http://schemas.openxmlformats.org/drawingml/2006/main" r:embed="Rc7b764c9c24840d9">
             <a:alphaModFix/>
           </a:blip>
           <a:srcRect xmlns:a="http://schemas.openxmlformats.org/drawingml/2006/main" l="0" t="0" r="0" b="0"/>
@@ -4505,7 +4547,7 @@
       </p:sp>
       <p:cxnSp>
         <p:nvCxnSpPr>
-          <p:cNvPr id="254" name="Google Shape;241;p12"/>
+          <p:cNvPr id="266" name="Google Shape;241;p12"/>
           <p:cNvCxnSpPr/>
           <p:nvPr/>
         </p:nvCxnSpPr>
@@ -9161,7 +9203,7 @@
       </p:sp>
       <p:cxnSp>
         <p:nvCxnSpPr>
-          <p:cNvPr id="343" name="Google Shape;330;p16"/>
+          <p:cNvPr id="355" name="Google Shape;330;p16"/>
           <p:cNvCxnSpPr/>
           <p:nvPr/>
         </p:nvCxnSpPr>
@@ -12788,7 +12830,7 @@
       </p:sp>
       <p:cxnSp>
         <p:nvCxnSpPr>
-          <p:cNvPr id="417" name="Google Shape;404;p19"/>
+          <p:cNvPr id="429" name="Google Shape;404;p19"/>
           <p:cNvCxnSpPr/>
           <p:nvPr/>
         </p:nvCxnSpPr>
@@ -17187,7 +17229,7 @@
       </p:sp>
       <p:cxnSp>
         <p:nvCxnSpPr>
-          <p:cNvPr id="119" name="Google Shape;89;p6"/>
+          <p:cNvPr id="145" name="Google Shape;89;p6"/>
           <p:cNvCxnSpPr/>
           <p:nvPr/>
         </p:nvCxnSpPr>
@@ -17328,7 +17370,7 @@
       </p:sp>
       <p:cxnSp>
         <p:nvCxnSpPr>
-          <p:cNvPr id="122" name="Google Shape;92;p6"/>
+          <p:cNvPr id="148" name="Google Shape;92;p6"/>
           <p:cNvCxnSpPr/>
           <p:nvPr/>
         </p:nvCxnSpPr>
@@ -17469,7 +17511,7 @@
       </p:sp>
       <p:cxnSp>
         <p:nvCxnSpPr>
-          <p:cNvPr id="125" name="Google Shape;95;p6"/>
+          <p:cNvPr id="151" name="Google Shape;95;p6"/>
           <p:cNvCxnSpPr/>
           <p:nvPr/>
         </p:nvCxnSpPr>
@@ -17610,7 +17652,7 @@
       </p:sp>
       <p:cxnSp>
         <p:nvCxnSpPr>
-          <p:cNvPr id="128" name="Google Shape;98;p6"/>
+          <p:cNvPr id="154" name="Google Shape;98;p6"/>
           <p:cNvCxnSpPr/>
           <p:nvPr/>
         </p:nvCxnSpPr>
@@ -17751,7 +17793,7 @@
       </p:sp>
       <p:cxnSp>
         <p:nvCxnSpPr>
-          <p:cNvPr id="131" name="Google Shape;101;p6"/>
+          <p:cNvPr id="157" name="Google Shape;101;p6"/>
           <p:cNvCxnSpPr/>
           <p:nvPr/>
         </p:nvCxnSpPr>
@@ -17892,7 +17934,7 @@
       </p:sp>
       <p:cxnSp>
         <p:nvCxnSpPr>
-          <p:cNvPr id="134" name="Google Shape;104;p6"/>
+          <p:cNvPr id="160" name="Google Shape;104;p6"/>
           <p:cNvCxnSpPr/>
           <p:nvPr/>
         </p:nvCxnSpPr>
@@ -21140,7 +21182,7 @@
       </p:sp>
       <p:cxnSp>
         <p:nvCxnSpPr>
-          <p:cNvPr id="185" name="Google Shape;172;p9"/>
+          <p:cNvPr id="197" name="Google Shape;172;p9"/>
           <p:cNvCxnSpPr/>
           <p:nvPr/>
         </p:nvCxnSpPr>

</xml_diff>